<commit_message>
Update lab guide and presentation titles to reflect Module 3 changes
</commit_message>
<xml_diff>
--- a/Module 3/module-03-day-3-lakehouse-warehouse-testing.pptx
+++ b/Module 3/module-03-day-3-lakehouse-warehouse-testing.pptx
@@ -134,6 +134,50 @@
 </p:presentation>
 </file>
 
+<file path=ppt/changesInfos/changesInfo1.xml><?xml version="1.0" encoding="utf-8"?>
+<pc:chgInfo xmlns:a="http://schemas.openxmlformats.org/drawingml/2006/main" xmlns:r="http://schemas.openxmlformats.org/officeDocument/2006/relationships" xmlns:ac="http://schemas.microsoft.com/office/drawing/2013/main/command" xmlns:pc="http://schemas.microsoft.com/office/powerpoint/2013/main/command">
+  <pc:docChgLst>
+    <pc:chgData name="Kishore" userId="d5d7dcb1-c230-4dcd-8c6f-b1fcba07fb95" providerId="ADAL" clId="{1AA63CBA-B78F-5B68-980E-9084EFF8E084}"/>
+    <pc:docChg chg="modSld">
+      <pc:chgData name="Kishore" userId="d5d7dcb1-c230-4dcd-8c6f-b1fcba07fb95" providerId="ADAL" clId="{1AA63CBA-B78F-5B68-980E-9084EFF8E084}" dt="2026-05-19T03:47:32.431" v="12" actId="20577"/>
+      <pc:docMkLst>
+        <pc:docMk/>
+      </pc:docMkLst>
+      <pc:sldChg chg="modSp mod">
+        <pc:chgData name="Kishore" userId="d5d7dcb1-c230-4dcd-8c6f-b1fcba07fb95" providerId="ADAL" clId="{1AA63CBA-B78F-5B68-980E-9084EFF8E084}" dt="2026-05-19T03:47:18.452" v="6" actId="14100"/>
+        <pc:sldMkLst>
+          <pc:docMk/>
+          <pc:sldMk cId="1790214794" sldId="256"/>
+        </pc:sldMkLst>
+        <pc:spChg chg="mod">
+          <ac:chgData name="Kishore" userId="d5d7dcb1-c230-4dcd-8c6f-b1fcba07fb95" providerId="ADAL" clId="{1AA63CBA-B78F-5B68-980E-9084EFF8E084}" dt="2026-05-19T03:47:18.452" v="6" actId="14100"/>
+          <ac:spMkLst>
+            <pc:docMk/>
+            <pc:sldMk cId="1790214794" sldId="256"/>
+            <ac:spMk id="9" creationId="{314F4B79-CAAF-4281-9C59-D4B906075EC0}"/>
+          </ac:spMkLst>
+        </pc:spChg>
+      </pc:sldChg>
+      <pc:sldChg chg="modSp mod">
+        <pc:chgData name="Kishore" userId="d5d7dcb1-c230-4dcd-8c6f-b1fcba07fb95" providerId="ADAL" clId="{1AA63CBA-B78F-5B68-980E-9084EFF8E084}" dt="2026-05-19T03:47:32.431" v="12" actId="20577"/>
+        <pc:sldMkLst>
+          <pc:docMk/>
+          <pc:sldMk cId="456914895" sldId="259"/>
+        </pc:sldMkLst>
+        <pc:spChg chg="mod">
+          <ac:chgData name="Kishore" userId="d5d7dcb1-c230-4dcd-8c6f-b1fcba07fb95" providerId="ADAL" clId="{1AA63CBA-B78F-5B68-980E-9084EFF8E084}" dt="2026-05-19T03:47:32.431" v="12" actId="20577"/>
+          <ac:spMkLst>
+            <pc:docMk/>
+            <pc:sldMk cId="456914895" sldId="259"/>
+            <ac:spMk id="8" creationId="{69C4E0E2-C13B-479A-AAA9-081A12A48E26}"/>
+          </ac:spMkLst>
+        </pc:spChg>
+      </pc:sldChg>
+    </pc:docChg>
+  </pc:docChgLst>
+</pc:chgInfo>
+</file>
+
 <file path=ppt/notesMasters/notesMaster1.xml><?xml version="1.0" encoding="utf-8"?>
 <p:notesMaster xmlns:a="http://schemas.openxmlformats.org/drawingml/2006/main" xmlns:r="http://schemas.openxmlformats.org/officeDocument/2006/relationships" xmlns:p="http://schemas.openxmlformats.org/presentationml/2006/main">
   <p:cSld>
@@ -6548,8 +6592,8 @@
         </p:nvSpPr>
         <p:spPr>
           <a:xfrm>
-            <a:off x="723900" y="1219200"/>
-            <a:ext cx="6477000" cy="990600"/>
+            <a:off x="723899" y="1219200"/>
+            <a:ext cx="7864515" cy="990600"/>
           </a:xfrm>
           <a:prstGeom prst="rect">
             <a:avLst/>
@@ -6583,7 +6627,7 @@
               </a:defRPr>
             </a:pPr>
             <a:r>
-              <a:rPr sz="3000" b="1">
+              <a:rPr lang="en-US" sz="3000" b="1" dirty="0">
                 <a:solidFill>
                   <a:srgbClr val="FFFFFF"/>
                 </a:solidFill>
@@ -6591,7 +6635,18 @@
                 <a:ea typeface="Caladea"/>
                 <a:cs typeface="Caladea"/>
               </a:rPr>
-              <a:t>Day 3: Lakehouse &amp; Warehouse Testing</a:t>
+              <a:t>Module</a:t>
+            </a:r>
+            <a:r>
+              <a:rPr sz="3000" b="1" dirty="0">
+                <a:solidFill>
+                  <a:srgbClr val="FFFFFF"/>
+                </a:solidFill>
+                <a:latin typeface="Caladea"/>
+                <a:ea typeface="Caladea"/>
+                <a:cs typeface="Caladea"/>
+              </a:rPr>
+              <a:t> 3: Lakehouse &amp; Warehouse Testing</a:t>
             </a:r>
           </a:p>
         </p:txBody>
@@ -24002,7 +24057,7 @@
               </a:defRPr>
             </a:pPr>
             <a:r>
-              <a:rPr sz="2400" b="1">
+              <a:rPr lang="en-US" sz="2400" b="1" dirty="0">
                 <a:solidFill>
                   <a:srgbClr val="122033"/>
                 </a:solidFill>
@@ -24010,7 +24065,18 @@
                 <a:ea typeface="Caladea"/>
                 <a:cs typeface="Caladea"/>
               </a:rPr>
-              <a:t>Day 3 learning objectives</a:t>
+              <a:t>Module</a:t>
+            </a:r>
+            <a:r>
+              <a:rPr sz="2400" b="1" dirty="0">
+                <a:solidFill>
+                  <a:srgbClr val="122033"/>
+                </a:solidFill>
+                <a:latin typeface="Caladea"/>
+                <a:ea typeface="Caladea"/>
+                <a:cs typeface="Caladea"/>
+              </a:rPr>
+              <a:t> 3 learning objectives</a:t>
             </a:r>
           </a:p>
         </p:txBody>

</xml_diff>